<commit_message>
alterações no pdf e mail
</commit_message>
<xml_diff>
--- a/apresentacao/Argus_Apresentacao.pptx
+++ b/apresentacao/Argus_Apresentacao.pptx
@@ -10352,7 +10352,7 @@
                 </a:solidFill>
                 <a:latin typeface="Calibri"/>
               </a:rPr>
-              <a:t>Os manuais e controles que protegem o banco</a:t>
+              <a:t>Os manuais e controles que protegem a instituição</a:t>
             </a:r>
           </a:p>
         </p:txBody>
@@ -10580,7 +10580,7 @@
                 </a:solidFill>
                 <a:latin typeface="Consolas"/>
               </a:rPr>
-              <a:t>BANCO / ARGUS — INÍCIO</a:t>
+              <a:t>O BANCO / ARGUS — INÍCIO</a:t>
             </a:r>
           </a:p>
         </p:txBody>
@@ -28397,7 +28397,7 @@
                 </a:solidFill>
                 <a:latin typeface="Calibri"/>
               </a:rPr>
-              <a:t>escalável; ~R$0 sob o banco</a:t>
+              <a:t>escalável; ~R$0 sob o parceiro</a:t>
             </a:r>
           </a:p>
         </p:txBody>
@@ -28568,7 +28568,7 @@
                 </a:solidFill>
                 <a:latin typeface="Calibri"/>
               </a:rPr>
-              <a:t>some se operar sob o banco</a:t>
+              <a:t>some se operar sob o parceiro</a:t>
             </a:r>
           </a:p>
         </p:txBody>
@@ -28739,7 +28739,7 @@
                 </a:solidFill>
                 <a:latin typeface="Calibri"/>
               </a:rPr>
-              <a:t>some se o banco já é associado</a:t>
+              <a:t>some se o parceiro já é associado</a:t>
             </a:r>
           </a:p>
         </p:txBody>
@@ -36166,7 +36166,7 @@
                 </a:solidFill>
                 <a:latin typeface="Calibri"/>
               </a:rPr>
-              <a:t>Banco responde · Argus executa</a:t>
+              <a:t>O banco responde · Argus executa</a:t>
             </a:r>
           </a:p>
         </p:txBody>
@@ -36679,7 +36679,7 @@
                 </a:solidFill>
                 <a:latin typeface="Calibri"/>
               </a:rPr>
-              <a:t>banco — sem licença nova</a:t>
+              <a:t>o banco — sem licença nova</a:t>
             </a:r>
           </a:p>
         </p:txBody>
@@ -36760,7 +36760,7 @@
                 </a:solidFill>
                 <a:latin typeface="Calibri"/>
               </a:rPr>
-              <a:t>Distribuir cotas dos fundos que ele mesmo administra quase sempre já está no escopo do banco (Lei 6.385, art. 15) — um eixo extra de valor, sem obter autorização nova.</a:t>
+              <a:t>Distribuir cotas dos fundos que ele mesmo administra é permitido ao administrador (Res. CVM 21, art. 33) — um eixo extra de valor, sem obter autorização nova.</a:t>
             </a:r>
           </a:p>
         </p:txBody>
@@ -43383,7 +43383,7 @@
                 </a:solidFill>
                 <a:latin typeface="Calibri"/>
               </a:rPr>
-              <a:t>Custos ao banco: registro CVM ~R$ 2.380 (uma vez) e fiscalização ~R$ 9.519/ano (administrador); custódia ~R$ 38.077/ano só se internalizar.</a:t>
+              <a:t>Custos ao parceiro: registro CVM ~R$ 2.380 (uma vez) e fiscalização ~R$ 9.519/ano (administrador); custódia ~R$ 38.077/ano só se internalizar.</a:t>
             </a:r>
           </a:p>
         </p:txBody>

</xml_diff>

<commit_message>
acabando nos onepages e emails
</commit_message>
<xml_diff>
--- a/apresentacao/Argus_Apresentacao.pptx
+++ b/apresentacao/Argus_Apresentacao.pptx
@@ -202,7 +202,7 @@
             <c:idx val="2"/>
             <c:spPr>
               <a:solidFill>
-                <a:srgbClr val="6A50AC"/>
+                <a:srgbClr val="B54A3A"/>
               </a:solidFill>
               <a:ln>
                 <a:noFill/>
@@ -213,7 +213,7 @@
             <c:idx val="3"/>
             <c:spPr>
               <a:solidFill>
-                <a:srgbClr val="6A50AC"/>
+                <a:srgbClr val="B54A3A"/>
               </a:solidFill>
               <a:ln>
                 <a:noFill/>
@@ -261,19 +261,19 @@
                 <c:formatCode>0.0"%"</c:formatCode>
                 <c:ptCount val="5"/>
                 <c:pt idx="0">
-                  <c:v>6.0</c:v>
+                  <c:v>20.0</c:v>
                 </c:pt>
                 <c:pt idx="1">
-                  <c:v>3.0</c:v>
+                  <c:v>10.0</c:v>
                 </c:pt>
                 <c:pt idx="2">
-                  <c:v>1.2</c:v>
+                  <c:v>4.0</c:v>
                 </c:pt>
                 <c:pt idx="3">
-                  <c:v>0.6</c:v>
+                  <c:v>2.0</c:v>
                 </c:pt>
                 <c:pt idx="4">
-                  <c:v>0.3</c:v>
+                  <c:v>1.0</c:v>
                 </c:pt>
               </c:numCache>
             </c:numRef>
@@ -448,7 +448,7 @@
                 <c:formatCode>"R$ "0" mil"</c:formatCode>
                 <c:ptCount val="2"/>
                 <c:pt idx="0">
-                  <c:v>60</c:v>
+                  <c:v>225</c:v>
                 </c:pt>
                 <c:pt idx="1">
                   <c:v>13</c:v>
@@ -6457,7 +6457,7 @@
                 </a:solidFill>
                 <a:latin typeface="Consolas"/>
               </a:rPr>
-              <a:t>Tradicional: R$ 50–70 mil/ano (InfoMoney). Argus: 1,29% de R$ 1 mi (custo total do modelo, planilha de custos).</a:t>
+              <a:t>Tradicional: pisos de mercado, R$ 150–300 mil/ano (mediana R$ 225 mil). Argus: 1,29% de R$ 1 mi (custo total do modelo, planilha de custos).</a:t>
             </a:r>
           </a:p>
         </p:txBody>
@@ -8112,7 +8112,7 @@
                 </a:solidFill>
                 <a:latin typeface="Calibri"/>
               </a:rPr>
-              <a:t>~R$ 50–70 mil/ano</a:t>
+              <a:t>~R$ 150–300 mil/ano</a:t>
             </a:r>
           </a:p>
         </p:txBody>
@@ -8202,7 +8202,7 @@
                 </a:solidFill>
                 <a:latin typeface="Calibri"/>
               </a:rPr>
-              <a:t>≈ 10× mais barato no fundo pequeno</a:t>
+              <a:t>25–50× mais barato no fundo pequeno</a:t>
             </a:r>
           </a:p>
         </p:txBody>
@@ -19699,7 +19699,7 @@
           <a:p>
             <a:pPr algn="l">
               <a:lnSpc>
-                <a:spcPct val="134000"/>
+                <a:spcPct val="130000"/>
               </a:lnSpc>
               <a:spcBef>
                 <a:spcPts val="0"/>
@@ -19715,13 +19715,13 @@
                 </a:solidFill>
                 <a:latin typeface="Calibri"/>
               </a:rPr>
-              <a:t>Um fundo pequeno carrega hoje R$ 50–70 mil por ano de custo fixo — gestão, administração, custódia, auditoria e taxa CVM — quase todo independente do tamanho do fundo.</a:t>
-            </a:r>
-          </a:p>
-          <a:p>
-            <a:pPr algn="l">
-              <a:lnSpc>
-                <a:spcPct val="134000"/>
+              <a:t>Nos pisos das administradoras tradicionais, um fundo carrega R$ 150–300 mil por ano de custo fixo — administração, custódia, controladoria, auditoria e taxa CVM — quase todo independente do tamanho do fundo.</a:t>
+            </a:r>
+          </a:p>
+          <a:p>
+            <a:pPr algn="l">
+              <a:lnSpc>
+                <a:spcPct val="130000"/>
               </a:lnSpc>
               <a:spcBef>
                 <a:spcPts val="0"/>
@@ -19743,7 +19743,7 @@
           <a:p>
             <a:pPr algn="l">
               <a:lnSpc>
-                <a:spcPct val="134000"/>
+                <a:spcPct val="130000"/>
               </a:lnSpc>
               <a:spcBef>
                 <a:spcPts val="0"/>
@@ -19759,7 +19759,7 @@
                 </a:solidFill>
                 <a:latin typeface="Calibri"/>
               </a:rPr>
-              <a:t>Num fundo de R$ 1 milhão, isso é 5–7% do patrimônio ao ano. Nenhum fundo sobrevive a isso. Por isso, na prática, só se abre um fundo a partir de ~R$ 10 milhões.</a:t>
+              <a:t>Num fundo de R$ 1 milhão, isso passa de 15% do patrimônio ao ano; mesmo nas casas mais enxutas (R$ 50–70 mil/ano), ainda são 5–7%. Na prática, só se abre um fundo a partir de ~R$ 20 milhões.</a:t>
             </a:r>
           </a:p>
         </p:txBody>
@@ -19804,7 +19804,7 @@
                 </a:solidFill>
                 <a:latin typeface="Consolas"/>
               </a:rPr>
-              <a:t>CUSTO FIXO ANUAL (~R$ 60 MIL) COMO % DO PL DO FUNDO</a:t>
+              <a:t>CUSTO FIXO ANUAL (~R$ 200 MIL) COMO % DO PL DO FUNDO</a:t>
             </a:r>
           </a:p>
         </p:txBody>
@@ -19867,7 +19867,7 @@
                 </a:solidFill>
                 <a:latin typeface="Consolas"/>
               </a:rPr>
-              <a:t>Custo fixo de um fundo pequeno: R$ 50–70 mil/ano (InfoMoney, 2023). % calculado sobre R$ 60 mil.</a:t>
+              <a:t>Pisos de mercado (adm + custódia + controladoria): R$ 12–25 mil/mês → R$ 150–300 mil/ano; % sobre R$ 200 mil. Casas enxutas: R$ 50–70 mil/ano (InfoMoney, 2023).</a:t>
             </a:r>
           </a:p>
         </p:txBody>
@@ -44162,7 +44162,7 @@
                 </a:solidFill>
                 <a:latin typeface="Calibri"/>
               </a:rPr>
-              <a:t>ANBIMA (~31 mil fundos, 976 gestoras, 51% &lt;R$400mi); ANCORD (27.515 assessores); InfoMoney (custo de fundo pequeno R$ 50–70 mil/ano).</a:t>
+              <a:t>ANBIMA (~31 mil fundos, 976 gestoras, 51% &lt;R$400mi); ANCORD (27.515 assessores); pisos de mercado R$ 150–300 mil/ano (regulamentos reais; casas enxutas R$ 50–70 mil — InfoMoney).</a:t>
             </a:r>
           </a:p>
         </p:txBody>

</xml_diff>